<commit_message>
docs: final ppt synopsis
</commit_message>
<xml_diff>
--- a/Synopsis/ppt.pptx
+++ b/Synopsis/ppt.pptx
@@ -17181,7 +17181,7 @@
                 <a:ea typeface="Times New Roman" pitchFamily="34" charset="-122"/>
                 <a:cs typeface="Times New Roman" pitchFamily="34" charset="-120"/>
               </a:rPr>
-              <a:t>is a retrieval method built for multi-step, information-seeking tasks, developed within the MIGRES framework. At each step, MIGRES provides the current question, the evidence collected so far, and the information still missing. Standard retrievers often keep returning documents that match the question but add nothing new. GAR addresses this by ranking documents on three factors: relevance to the missing information, how much of that information they cover, and how new they are compared to existing evidence. It uses a fixed sentence embedding model, approximate nearest neighbor search, and a weighted scoring function to combine these factors. GAR is evaluated against BM25, DPR, Contriever, ColBERTv2, and SPLADE on retrieval quality, answer quality, component contribution, efficiency, and reproducibility, to determine whether modeling the information gap improves iterative retrieval.</a:t>
+              <a:t>is the retrieval strategy investigated in this project to improve iterative Retrieval-Augmented Generation (RAG). RAG systems retrieve external information to support answer generation by large language models, but in complex, multi-hop questions, conventional retrieval methods may repeatedly retrieve information that is already available instead of focusing on what is still missing, limiting the effectiveness of iterative retrieval. This project is motivated by the MIGRES framework, which guides iterative retrieval using missing information. Based on the study of MIGRES and related retrieval approaches, this work will investigate using the current information gap and previously collected evidence to guide document retrieval, exploring whether gap relevance, gap coverage, and evidence novelty can improve the selection of useful documents. The study will investigate whether explicitly incorporating the information gap and prior evidence into the retrieval process can lead to more useful evidence selection in iterative RAG. A suitable retrieval strategy will be studied and developed within the MIGRES framework and evaluated against established retrieval approaches.</a:t>
             </a:r>
             <a:endParaRPr lang="en-US" sz="1350" dirty="0"/>
           </a:p>
@@ -17509,7 +17509,7 @@
                 <a:ea typeface="Times New Roman" pitchFamily="34" charset="-122"/>
                 <a:cs typeface="Times New Roman" pitchFamily="34" charset="-120"/>
               </a:rPr>
-              <a:t>Retrieval-Augmented Generation (RAG) combines a language model with document search, so the quality of retrieved documents strongly affects the final answer. Standard retrieval mainly matches documents to the original query, which is limiting for multi-hop questions that require combining information across documents. After an initial search, some information is found while other information remains missing, and further searches based only on the original query tend to return similar results. The MIGRES framework addresses this by identifying missing information after each search step and using it to guide the next retrieval. Related work has explored similar directions, such as measuring whether new documents add genuinely new information (Relevant Information Gain, InfoGain-RAG), assessing source reliability, and efficient matching methods like ColBERTv2. Building on these ideas, this project investigates Gap-Aware Retrieval (GAR), to determine whether the current information gap and previously collected evidence can jointly guide iterative retrieval.</a:t>
+              <a:t>Retrieval-Augmented Generation (RAG) combines information retrieval with large language models (LLMs) to improve answer generation using external documents, so the quality of retrieved information strongly affects the final answer. Standard retrieval mainly matches documents to the original query, which is limiting for multi-hop questions that require combining information across documents. After an initial search, some information is found while other information may still be missing, and further searches based only on the original query may return repeated or less useful results. The MIGRES framework addresses this by using missing information to guide the next retrieval step. Related work has explored similar directions, such as measuring whether new documents add genuinely new information (Relevant Information Gain, InfoGain-RAG), assessing source reliability, and efficient matching methods like ColBERTv2. Based on this, the project will investigate how iterative retrieval can make better use of information already collected and information still required, exploring a strategy referred to as Gap-Aware Retrieval (GAR) that considers gap relevance, gap coverage, and evidence novelty during document selection.</a:t>
             </a:r>
             <a:r>
               <a:rPr lang="en-US" sz="1400" dirty="0" smtClean="0">

</xml_diff>